<commit_message>
Remove speaker notes from deck; add analysis notebooks; update docs
- Strip all embedded speaker notes from the presentation (0 notes remain)
- Add notebooks/: initial analysis (Jeff_modeling.ipynb) and the Phase-1
  corrections/verification notebook (Jeff_modeling_Phase1_Corrections.ipynb)
- README: document the notebooks; drop the "speaker notes" mention

Co-Authored-By: Claude Opus 4.8 <noreply@anthropic.com>
</commit_message>
<xml_diff>
--- a/presentation/Markets-Speak-in-Regimes-Slides.pptx
+++ b/presentation/Markets-Speak-in-Regimes-Slides.pptx
@@ -762,1150 +762,6 @@
     </a:lvl9pPr>
   </p:notesStyle>
 </p:notesMaster>
-</file>
-
-<file path=ppt/notesSlides/notesSlide1.xml><?xml version="1.0" encoding="utf-8"?>
-<p:notes xmlns:a="http://schemas.openxmlformats.org/drawingml/2006/main" xmlns:r="http://schemas.openxmlformats.org/officeDocument/2006/relationships" xmlns:p="http://schemas.openxmlformats.org/presentationml/2006/main">
-  <p:cSld>
-    <p:spTree>
-      <p:nvGrpSpPr>
-        <p:cNvPr id="1" name=""/>
-        <p:cNvGrpSpPr/>
-        <p:nvPr/>
-      </p:nvGrpSpPr>
-      <p:grpSpPr>
-        <a:xfrm>
-          <a:off x="0" y="0"/>
-          <a:ext cx="0" cy="0"/>
-          <a:chOff x="0" y="0"/>
-          <a:chExt cx="0" cy="0"/>
-        </a:xfrm>
-      </p:grpSpPr>
-      <p:sp>
-        <p:nvSpPr>
-          <p:cNvPr id="2" name="Slide Image Placeholder 1"/>
-          <p:cNvSpPr>
-            <a:spLocks noGrp="1" noRot="1" noChangeAspect="1"/>
-          </p:cNvSpPr>
-          <p:nvPr>
-            <p:ph type="sldImg"/>
-          </p:nvPr>
-        </p:nvSpPr>
-        <p:spPr/>
-      </p:sp>
-      <p:sp>
-        <p:nvSpPr>
-          <p:cNvPr id="3" name="Notes Placeholder 2"/>
-          <p:cNvSpPr>
-            <a:spLocks noGrp="1"/>
-          </p:cNvSpPr>
-          <p:nvPr>
-            <p:ph type="body" idx="1"/>
-          </p:nvPr>
-        </p:nvSpPr>
-        <p:spPr/>
-        <p:txBody>
-          <a:bodyPr/>
-          <a:lstStyle/>
-          <a:p>
-            <a:r>
-              <a:rPr lang="en-US" dirty="0"/>
-              <a:t>Welcome. This presentation covers the methodology and findings of a quantitative equity risk analysis on Safaricom (SCOM.NSE). The central thesis: we can predict WHEN this market will be risky — even when we cannot predict WHERE prices will go. The Vodacom acquisition, which closed yesterday, serves as a live validation of our framework.</a:t>
-            </a:r>
-            <a:endParaRPr lang="en-US" dirty="0"/>
-          </a:p>
-        </p:txBody>
-      </p:sp>
-      <p:sp>
-        <p:nvSpPr>
-          <p:cNvPr id="4" name="Slide Number Placeholder 3"/>
-          <p:cNvSpPr>
-            <a:spLocks noGrp="1"/>
-          </p:cNvSpPr>
-          <p:nvPr>
-            <p:ph type="sldNum" sz="quarter" idx="10"/>
-          </p:nvPr>
-        </p:nvSpPr>
-        <p:spPr/>
-        <p:txBody>
-          <a:bodyPr/>
-          <a:lstStyle/>
-          <a:p>
-            <a:fld id="{F7021451-1387-4CA6-816F-3879F97B5CBC}" type="slidenum">
-              <a:rPr lang="en-US"/>
-              <a:t>1</a:t>
-            </a:fld>
-            <a:endParaRPr lang="en-US"/>
-          </a:p>
-        </p:txBody>
-      </p:sp>
-    </p:spTree>
-    <p:extLst>
-      <p:ext uri="{BB962C8B-B14F-4D97-AF65-F5344CB8AC3E}">
-        <p14:creationId xmlns:p14="http://schemas.microsoft.com/office/powerpoint/2010/main" val="1024086991"/>
-      </p:ext>
-    </p:extLst>
-  </p:cSld>
-  <p:clrMapOvr>
-    <a:masterClrMapping/>
-  </p:clrMapOvr>
-</p:notes>
-</file>
-
-<file path=ppt/notesSlides/notesSlide10.xml><?xml version="1.0" encoding="utf-8"?>
-<p:notes xmlns:a="http://schemas.openxmlformats.org/drawingml/2006/main" xmlns:r="http://schemas.openxmlformats.org/officeDocument/2006/relationships" xmlns:p="http://schemas.openxmlformats.org/presentationml/2006/main">
-  <p:cSld>
-    <p:spTree>
-      <p:nvGrpSpPr>
-        <p:cNvPr id="1" name=""/>
-        <p:cNvGrpSpPr/>
-        <p:nvPr/>
-      </p:nvGrpSpPr>
-      <p:grpSpPr>
-        <a:xfrm>
-          <a:off x="0" y="0"/>
-          <a:ext cx="0" cy="0"/>
-          <a:chOff x="0" y="0"/>
-          <a:chExt cx="0" cy="0"/>
-        </a:xfrm>
-      </p:grpSpPr>
-      <p:sp>
-        <p:nvSpPr>
-          <p:cNvPr id="2" name="Slide Image Placeholder 1"/>
-          <p:cNvSpPr>
-            <a:spLocks noGrp="1" noRot="1" noChangeAspect="1"/>
-          </p:cNvSpPr>
-          <p:nvPr>
-            <p:ph type="sldImg"/>
-          </p:nvPr>
-        </p:nvSpPr>
-        <p:spPr/>
-      </p:sp>
-      <p:sp>
-        <p:nvSpPr>
-          <p:cNvPr id="3" name="Notes Placeholder 2"/>
-          <p:cNvSpPr>
-            <a:spLocks noGrp="1"/>
-          </p:cNvSpPr>
-          <p:nvPr>
-            <p:ph type="body" idx="1"/>
-          </p:nvPr>
-        </p:nvSpPr>
-        <p:spPr/>
-        <p:txBody>
-          <a:bodyPr/>
-          <a:lstStyle/>
-          <a:p>
-            <a:r>
-              <a:rPr lang="en-US" dirty="0"/>
-              <a:t>Walk through the timeline. The key statistical point: the announcement date of Dec 4, 2025 should show up as a change-point in the Zivot-Andrews test and ruptures PELT algorithm. Price rallied +91% from the KES 15 low — that's a regime transition in price space. The analytical insight: our framework predicted that regime transitions ARE detectable. The Vodacom deal is post-sample validation — we didn't fit the model to this event. The dashboard makes this concrete: in Tab 3, once the post-Jun-2026 data is loaded, the model shades the post-takeover period as its own volatility-regime episode — the visual proof of out-of-sample detection.</a:t>
-            </a:r>
-            <a:endParaRPr lang="en-US" dirty="0"/>
-          </a:p>
-        </p:txBody>
-      </p:sp>
-      <p:sp>
-        <p:nvSpPr>
-          <p:cNvPr id="4" name="Slide Number Placeholder 3"/>
-          <p:cNvSpPr>
-            <a:spLocks noGrp="1"/>
-          </p:cNvSpPr>
-          <p:nvPr>
-            <p:ph type="sldNum" sz="quarter" idx="10"/>
-          </p:nvPr>
-        </p:nvSpPr>
-        <p:spPr/>
-        <p:txBody>
-          <a:bodyPr/>
-          <a:lstStyle/>
-          <a:p>
-            <a:fld id="{F7021451-1387-4CA6-816F-3879F97B5CBC}" type="slidenum">
-              <a:rPr lang="en-US"/>
-              <a:t>10</a:t>
-            </a:fld>
-            <a:endParaRPr lang="en-US"/>
-          </a:p>
-        </p:txBody>
-      </p:sp>
-    </p:spTree>
-    <p:extLst>
-      <p:ext uri="{BB962C8B-B14F-4D97-AF65-F5344CB8AC3E}">
-        <p14:creationId xmlns:p14="http://schemas.microsoft.com/office/powerpoint/2010/main" val="1024086991"/>
-      </p:ext>
-    </p:extLst>
-  </p:cSld>
-  <p:clrMapOvr>
-    <a:masterClrMapping/>
-  </p:clrMapOvr>
-</p:notes>
-</file>
-
-<file path=ppt/notesSlides/notesSlide11.xml><?xml version="1.0" encoding="utf-8"?>
-<p:notes xmlns:a="http://schemas.openxmlformats.org/drawingml/2006/main" xmlns:r="http://schemas.openxmlformats.org/officeDocument/2006/relationships" xmlns:p="http://schemas.openxmlformats.org/presentationml/2006/main">
-  <p:cSld>
-    <p:spTree>
-      <p:nvGrpSpPr>
-        <p:cNvPr id="1" name=""/>
-        <p:cNvGrpSpPr/>
-        <p:nvPr/>
-      </p:nvGrpSpPr>
-      <p:grpSpPr>
-        <a:xfrm>
-          <a:off x="0" y="0"/>
-          <a:ext cx="0" cy="0"/>
-          <a:chOff x="0" y="0"/>
-          <a:chExt cx="0" cy="0"/>
-        </a:xfrm>
-      </p:grpSpPr>
-      <p:sp>
-        <p:nvSpPr>
-          <p:cNvPr id="2" name="Slide Image Placeholder 1"/>
-          <p:cNvSpPr>
-            <a:spLocks noGrp="1" noRot="1" noChangeAspect="1"/>
-          </p:cNvSpPr>
-          <p:nvPr>
-            <p:ph type="sldImg"/>
-          </p:nvPr>
-        </p:nvSpPr>
-        <p:spPr/>
-      </p:sp>
-      <p:sp>
-        <p:nvSpPr>
-          <p:cNvPr id="3" name="Notes Placeholder 2"/>
-          <p:cNvSpPr>
-            <a:spLocks noGrp="1"/>
-          </p:cNvSpPr>
-          <p:nvPr>
-            <p:ph type="body" idx="1"/>
-          </p:nvPr>
-        </p:nvSpPr>
-        <p:spPr/>
-        <p:txBody>
-          <a:bodyPr/>
-          <a:lstStyle/>
-          <a:p>
-            <a:r>
-              <a:rPr lang="en-US" dirty="0"/>
-              <a:t>This is the live demo slide. Switch to your terminal and run the Streamlit app. Walk through each tab: Tab 1 — show the price chart, toggle Vodacom events on. Tab 2 — show rolling vol, point out how vol spiked around Dec 2025 announcement. Tab 3 — the regime view now shades the series into volatility episodes (Ruptures PELT), each band coloured by its GMM regime with the price line on top; read out the current regime and use the sidebar Regime episode sensitivity slider to widen or refine the bands. Once the EODHD data extends past the Jun 30 2026 close, a distinct post-takeover band appears with an out-of-sample bracket — that is the theory validating itself live. Tab 4 — show the VaR chart and point out that the live Kupiec + Christoffersen backtest PASSES (5.9%, p=0.16); frame GJR-GARCH/EVT as tail-sharpening, not a fix. The sidebar confidence slider is interactive — adjust it live.</a:t>
-            </a:r>
-            <a:endParaRPr lang="en-US" dirty="0"/>
-          </a:p>
-        </p:txBody>
-      </p:sp>
-      <p:sp>
-        <p:nvSpPr>
-          <p:cNvPr id="4" name="Slide Number Placeholder 3"/>
-          <p:cNvSpPr>
-            <a:spLocks noGrp="1"/>
-          </p:cNvSpPr>
-          <p:nvPr>
-            <p:ph type="sldNum" sz="quarter" idx="10"/>
-          </p:nvPr>
-        </p:nvSpPr>
-        <p:spPr/>
-        <p:txBody>
-          <a:bodyPr/>
-          <a:lstStyle/>
-          <a:p>
-            <a:fld id="{F7021451-1387-4CA6-816F-3879F97B5CBC}" type="slidenum">
-              <a:rPr lang="en-US"/>
-              <a:t>11</a:t>
-            </a:fld>
-            <a:endParaRPr lang="en-US"/>
-          </a:p>
-        </p:txBody>
-      </p:sp>
-    </p:spTree>
-    <p:extLst>
-      <p:ext uri="{BB962C8B-B14F-4D97-AF65-F5344CB8AC3E}">
-        <p14:creationId xmlns:p14="http://schemas.microsoft.com/office/powerpoint/2010/main" val="1024086991"/>
-      </p:ext>
-    </p:extLst>
-  </p:cSld>
-  <p:clrMapOvr>
-    <a:masterClrMapping/>
-  </p:clrMapOvr>
-</p:notes>
-</file>
-
-<file path=ppt/notesSlides/notesSlide12.xml><?xml version="1.0" encoding="utf-8"?>
-<p:notes xmlns:a="http://schemas.openxmlformats.org/drawingml/2006/main" xmlns:r="http://schemas.openxmlformats.org/officeDocument/2006/relationships" xmlns:p="http://schemas.openxmlformats.org/presentationml/2006/main">
-  <p:cSld>
-    <p:spTree>
-      <p:nvGrpSpPr>
-        <p:cNvPr id="1" name=""/>
-        <p:cNvGrpSpPr/>
-        <p:nvPr/>
-      </p:nvGrpSpPr>
-      <p:grpSpPr>
-        <a:xfrm>
-          <a:off x="0" y="0"/>
-          <a:ext cx="0" cy="0"/>
-          <a:chOff x="0" y="0"/>
-          <a:chExt cx="0" cy="0"/>
-        </a:xfrm>
-      </p:grpSpPr>
-      <p:sp>
-        <p:nvSpPr>
-          <p:cNvPr id="2" name="Slide Image Placeholder 1"/>
-          <p:cNvSpPr>
-            <a:spLocks noGrp="1" noRot="1" noChangeAspect="1"/>
-          </p:cNvSpPr>
-          <p:nvPr>
-            <p:ph type="sldImg"/>
-          </p:nvPr>
-        </p:nvSpPr>
-        <p:spPr/>
-      </p:sp>
-      <p:sp>
-        <p:nvSpPr>
-          <p:cNvPr id="3" name="Notes Placeholder 2"/>
-          <p:cNvSpPr>
-            <a:spLocks noGrp="1"/>
-          </p:cNvSpPr>
-          <p:nvPr>
-            <p:ph type="body" idx="1"/>
-          </p:nvPr>
-        </p:nvSpPr>
-        <p:spPr/>
-        <p:txBody>
-          <a:bodyPr/>
-          <a:lstStyle/>
-          <a:p>
-            <a:r>
-              <a:rPr lang="en-US" dirty="0"/>
-              <a:t>Three clear phases. Phase 1 is done — that's what we just presented. Phase 2 is the dashboard you just saw running live. Phase 3 is the product: a real-time internal tool that gives a regime signal and risk budget recommendation every trading day. The GJR-GARCH and EVT enhancements sharpen the extreme tail of the already-validated VaR from slide 8 — they raise precision, they don't repair a failure.</a:t>
-            </a:r>
-            <a:endParaRPr lang="en-US" dirty="0"/>
-          </a:p>
-        </p:txBody>
-      </p:sp>
-      <p:sp>
-        <p:nvSpPr>
-          <p:cNvPr id="4" name="Slide Number Placeholder 3"/>
-          <p:cNvSpPr>
-            <a:spLocks noGrp="1"/>
-          </p:cNvSpPr>
-          <p:nvPr>
-            <p:ph type="sldNum" sz="quarter" idx="10"/>
-          </p:nvPr>
-        </p:nvSpPr>
-        <p:spPr/>
-        <p:txBody>
-          <a:bodyPr/>
-          <a:lstStyle/>
-          <a:p>
-            <a:fld id="{F7021451-1387-4CA6-816F-3879F97B5CBC}" type="slidenum">
-              <a:rPr lang="en-US"/>
-              <a:t>12</a:t>
-            </a:fld>
-            <a:endParaRPr lang="en-US"/>
-          </a:p>
-        </p:txBody>
-      </p:sp>
-    </p:spTree>
-    <p:extLst>
-      <p:ext uri="{BB962C8B-B14F-4D97-AF65-F5344CB8AC3E}">
-        <p14:creationId xmlns:p14="http://schemas.microsoft.com/office/powerpoint/2010/main" val="1024086991"/>
-      </p:ext>
-    </p:extLst>
-  </p:cSld>
-  <p:clrMapOvr>
-    <a:masterClrMapping/>
-  </p:clrMapOvr>
-</p:notes>
-</file>
-
-<file path=ppt/notesSlides/notesSlide13.xml><?xml version="1.0" encoding="utf-8"?>
-<p:notes xmlns:a="http://schemas.openxmlformats.org/drawingml/2006/main" xmlns:r="http://schemas.openxmlformats.org/officeDocument/2006/relationships" xmlns:p="http://schemas.openxmlformats.org/presentationml/2006/main">
-  <p:cSld>
-    <p:spTree>
-      <p:nvGrpSpPr>
-        <p:cNvPr id="1" name=""/>
-        <p:cNvGrpSpPr/>
-        <p:nvPr/>
-      </p:nvGrpSpPr>
-      <p:grpSpPr>
-        <a:xfrm>
-          <a:off x="0" y="0"/>
-          <a:ext cx="0" cy="0"/>
-          <a:chOff x="0" y="0"/>
-          <a:chExt cx="0" cy="0"/>
-        </a:xfrm>
-      </p:grpSpPr>
-      <p:sp>
-        <p:nvSpPr>
-          <p:cNvPr id="2" name="Slide Image Placeholder 1"/>
-          <p:cNvSpPr>
-            <a:spLocks noGrp="1" noRot="1" noChangeAspect="1"/>
-          </p:cNvSpPr>
-          <p:nvPr>
-            <p:ph type="sldImg"/>
-          </p:nvPr>
-        </p:nvSpPr>
-        <p:spPr/>
-      </p:sp>
-      <p:sp>
-        <p:nvSpPr>
-          <p:cNvPr id="3" name="Notes Placeholder 2"/>
-          <p:cNvSpPr>
-            <a:spLocks noGrp="1"/>
-          </p:cNvSpPr>
-          <p:nvPr>
-            <p:ph type="body" idx="1"/>
-          </p:nvPr>
-        </p:nvSpPr>
-        <p:spPr/>
-        <p:txBody>
-          <a:bodyPr/>
-          <a:lstStyle/>
-          <a:p>
-            <a:r>
-              <a:rPr lang="en-US" dirty="0"/>
-              <a:t>Likely questions to prepare for: Q: 'How do we use this operationally?' — A: Regime signal + position-sizing table (slide 7). Q: 'Why not a neural network?' — A: Interpretability. We need to explain risk to compliance. GARCH is industry standard. Q: 'What about other NSE stocks?' — A: Same pipeline applies. SAFCOM is the proof of concept. Q: 'Is the VaR model safe to use?' — A: It passes both Kupiec (coverage) and Christoffersen (independence), so it's validated for analysis and risk signalling; GJR-GARCH/EVT sharpen the extreme tail before large-scale capital allocation. Q: 'What about the Vodacom data since Jun 30?' — A: Limited trading history yet, but we'll re-calibrate as data accumulates.</a:t>
-            </a:r>
-            <a:endParaRPr lang="en-US" dirty="0"/>
-          </a:p>
-        </p:txBody>
-      </p:sp>
-      <p:sp>
-        <p:nvSpPr>
-          <p:cNvPr id="4" name="Slide Number Placeholder 3"/>
-          <p:cNvSpPr>
-            <a:spLocks noGrp="1"/>
-          </p:cNvSpPr>
-          <p:nvPr>
-            <p:ph type="sldNum" sz="quarter" idx="10"/>
-          </p:nvPr>
-        </p:nvSpPr>
-        <p:spPr/>
-        <p:txBody>
-          <a:bodyPr/>
-          <a:lstStyle/>
-          <a:p>
-            <a:fld id="{F7021451-1387-4CA6-816F-3879F97B5CBC}" type="slidenum">
-              <a:rPr lang="en-US"/>
-              <a:t>13</a:t>
-            </a:fld>
-            <a:endParaRPr lang="en-US"/>
-          </a:p>
-        </p:txBody>
-      </p:sp>
-    </p:spTree>
-    <p:extLst>
-      <p:ext uri="{BB962C8B-B14F-4D97-AF65-F5344CB8AC3E}">
-        <p14:creationId xmlns:p14="http://schemas.microsoft.com/office/powerpoint/2010/main" val="1024086991"/>
-      </p:ext>
-    </p:extLst>
-  </p:cSld>
-  <p:clrMapOvr>
-    <a:masterClrMapping/>
-  </p:clrMapOvr>
-</p:notes>
-</file>
-
-<file path=ppt/notesSlides/notesSlide2.xml><?xml version="1.0" encoding="utf-8"?>
-<p:notes xmlns:a="http://schemas.openxmlformats.org/drawingml/2006/main" xmlns:r="http://schemas.openxmlformats.org/officeDocument/2006/relationships" xmlns:p="http://schemas.openxmlformats.org/presentationml/2006/main">
-  <p:cSld>
-    <p:spTree>
-      <p:nvGrpSpPr>
-        <p:cNvPr id="1" name=""/>
-        <p:cNvGrpSpPr/>
-        <p:nvPr/>
-      </p:nvGrpSpPr>
-      <p:grpSpPr>
-        <a:xfrm>
-          <a:off x="0" y="0"/>
-          <a:ext cx="0" cy="0"/>
-          <a:chOff x="0" y="0"/>
-          <a:chExt cx="0" cy="0"/>
-        </a:xfrm>
-      </p:grpSpPr>
-      <p:sp>
-        <p:nvSpPr>
-          <p:cNvPr id="2" name="Slide Image Placeholder 1"/>
-          <p:cNvSpPr>
-            <a:spLocks noGrp="1" noRot="1" noChangeAspect="1"/>
-          </p:cNvSpPr>
-          <p:nvPr>
-            <p:ph type="sldImg"/>
-          </p:nvPr>
-        </p:nvSpPr>
-        <p:spPr/>
-      </p:sp>
-      <p:sp>
-        <p:nvSpPr>
-          <p:cNvPr id="3" name="Notes Placeholder 2"/>
-          <p:cNvSpPr>
-            <a:spLocks noGrp="1"/>
-          </p:cNvSpPr>
-          <p:nvPr>
-            <p:ph type="body" idx="1"/>
-          </p:nvPr>
-        </p:nvSpPr>
-        <p:spPr/>
-        <p:txBody>
-          <a:bodyPr/>
-          <a:lstStyle/>
-          <a:p>
-            <a:r>
-              <a:rPr lang="en-US" dirty="0"/>
-              <a:t>The key reframe: we're not building a price predictor. We're building a regime detector — a model that tells us whether the market is in a calm, trending, stressed, or crisis state. That information is directly actionable for portfolio risk management: position sizing, stop-losses, hedging decisions.</a:t>
-            </a:r>
-            <a:endParaRPr lang="en-US" dirty="0"/>
-          </a:p>
-        </p:txBody>
-      </p:sp>
-      <p:sp>
-        <p:nvSpPr>
-          <p:cNvPr id="4" name="Slide Number Placeholder 3"/>
-          <p:cNvSpPr>
-            <a:spLocks noGrp="1"/>
-          </p:cNvSpPr>
-          <p:nvPr>
-            <p:ph type="sldNum" sz="quarter" idx="10"/>
-          </p:nvPr>
-        </p:nvSpPr>
-        <p:spPr/>
-        <p:txBody>
-          <a:bodyPr/>
-          <a:lstStyle/>
-          <a:p>
-            <a:fld id="{F7021451-1387-4CA6-816F-3879F97B5CBC}" type="slidenum">
-              <a:rPr lang="en-US"/>
-              <a:t>2</a:t>
-            </a:fld>
-            <a:endParaRPr lang="en-US"/>
-          </a:p>
-        </p:txBody>
-      </p:sp>
-    </p:spTree>
-    <p:extLst>
-      <p:ext uri="{BB962C8B-B14F-4D97-AF65-F5344CB8AC3E}">
-        <p14:creationId xmlns:p14="http://schemas.microsoft.com/office/powerpoint/2010/main" val="1024086991"/>
-      </p:ext>
-    </p:extLst>
-  </p:cSld>
-  <p:clrMapOvr>
-    <a:masterClrMapping/>
-  </p:clrMapOvr>
-</p:notes>
-</file>
-
-<file path=ppt/notesSlides/notesSlide3.xml><?xml version="1.0" encoding="utf-8"?>
-<p:notes xmlns:a="http://schemas.openxmlformats.org/drawingml/2006/main" xmlns:r="http://schemas.openxmlformats.org/officeDocument/2006/relationships" xmlns:p="http://schemas.openxmlformats.org/presentationml/2006/main">
-  <p:cSld>
-    <p:spTree>
-      <p:nvGrpSpPr>
-        <p:cNvPr id="1" name=""/>
-        <p:cNvGrpSpPr/>
-        <p:nvPr/>
-      </p:nvGrpSpPr>
-      <p:grpSpPr>
-        <a:xfrm>
-          <a:off x="0" y="0"/>
-          <a:ext cx="0" cy="0"/>
-          <a:chOff x="0" y="0"/>
-          <a:chExt cx="0" cy="0"/>
-        </a:xfrm>
-      </p:grpSpPr>
-      <p:sp>
-        <p:nvSpPr>
-          <p:cNvPr id="2" name="Slide Image Placeholder 1"/>
-          <p:cNvSpPr>
-            <a:spLocks noGrp="1" noRot="1" noChangeAspect="1"/>
-          </p:cNvSpPr>
-          <p:nvPr>
-            <p:ph type="sldImg"/>
-          </p:nvPr>
-        </p:nvSpPr>
-        <p:spPr/>
-      </p:sp>
-      <p:sp>
-        <p:nvSpPr>
-          <p:cNvPr id="3" name="Notes Placeholder 2"/>
-          <p:cNvSpPr>
-            <a:spLocks noGrp="1"/>
-          </p:cNvSpPr>
-          <p:nvPr>
-            <p:ph type="body" idx="1"/>
-          </p:nvPr>
-        </p:nvSpPr>
-        <p:spPr/>
-        <p:txBody>
-          <a:bodyPr/>
-          <a:lstStyle/>
-          <a:p>
-            <a:r>
-              <a:rPr lang="en-US" dirty="0"/>
-              <a:t>Walk through the pipeline left to right. Each step feeds the next. The GARCH model was fitted on ~2,500 trading days for statistical robustness — that's roughly 10 years of daily data. The GMM regime detection then operates on the GARCH-filtered residuals to identify the underlying volatility state.</a:t>
-            </a:r>
-            <a:endParaRPr lang="en-US" dirty="0"/>
-          </a:p>
-        </p:txBody>
-      </p:sp>
-      <p:sp>
-        <p:nvSpPr>
-          <p:cNvPr id="4" name="Slide Number Placeholder 3"/>
-          <p:cNvSpPr>
-            <a:spLocks noGrp="1"/>
-          </p:cNvSpPr>
-          <p:nvPr>
-            <p:ph type="sldNum" sz="quarter" idx="10"/>
-          </p:nvPr>
-        </p:nvSpPr>
-        <p:spPr/>
-        <p:txBody>
-          <a:bodyPr/>
-          <a:lstStyle/>
-          <a:p>
-            <a:fld id="{F7021451-1387-4CA6-816F-3879F97B5CBC}" type="slidenum">
-              <a:rPr lang="en-US"/>
-              <a:t>3</a:t>
-            </a:fld>
-            <a:endParaRPr lang="en-US"/>
-          </a:p>
-        </p:txBody>
-      </p:sp>
-    </p:spTree>
-    <p:extLst>
-      <p:ext uri="{BB962C8B-B14F-4D97-AF65-F5344CB8AC3E}">
-        <p14:creationId xmlns:p14="http://schemas.microsoft.com/office/powerpoint/2010/main" val="1024086991"/>
-      </p:ext>
-    </p:extLst>
-  </p:cSld>
-  <p:clrMapOvr>
-    <a:masterClrMapping/>
-  </p:clrMapOvr>
-</p:notes>
-</file>
-
-<file path=ppt/notesSlides/notesSlide4.xml><?xml version="1.0" encoding="utf-8"?>
-<p:notes xmlns:a="http://schemas.openxmlformats.org/drawingml/2006/main" xmlns:r="http://schemas.openxmlformats.org/officeDocument/2006/relationships" xmlns:p="http://schemas.openxmlformats.org/presentationml/2006/main">
-  <p:cSld>
-    <p:spTree>
-      <p:nvGrpSpPr>
-        <p:cNvPr id="1" name=""/>
-        <p:cNvGrpSpPr/>
-        <p:nvPr/>
-      </p:nvGrpSpPr>
-      <p:grpSpPr>
-        <a:xfrm>
-          <a:off x="0" y="0"/>
-          <a:ext cx="0" cy="0"/>
-          <a:chOff x="0" y="0"/>
-          <a:chExt cx="0" cy="0"/>
-        </a:xfrm>
-      </p:grpSpPr>
-      <p:sp>
-        <p:nvSpPr>
-          <p:cNvPr id="2" name="Slide Image Placeholder 1"/>
-          <p:cNvSpPr>
-            <a:spLocks noGrp="1" noRot="1" noChangeAspect="1"/>
-          </p:cNvSpPr>
-          <p:nvPr>
-            <p:ph type="sldImg"/>
-          </p:nvPr>
-        </p:nvSpPr>
-        <p:spPr/>
-      </p:sp>
-      <p:sp>
-        <p:nvSpPr>
-          <p:cNvPr id="3" name="Notes Placeholder 2"/>
-          <p:cNvSpPr>
-            <a:spLocks noGrp="1"/>
-          </p:cNvSpPr>
-          <p:nvPr>
-            <p:ph type="body" idx="1"/>
-          </p:nvPr>
-        </p:nvSpPr>
-        <p:spPr/>
-        <p:txBody>
-          <a:bodyPr/>
-          <a:lstStyle/>
-          <a:p>
-            <a:r>
-              <a:rPr lang="en-US" dirty="0"/>
-              <a:t>The +91% price recovery is the attention-grabber, but that's not the point. The ARCH LM p-value of 1.2×10⁻²² is essentially zero — volatility is NOT random white noise. It has structure. That structure is what the GARCH model captures. Skewness of +0.32 means large positive shocks happen more often than the normal distribution expects.</a:t>
-            </a:r>
-            <a:endParaRPr lang="en-US" dirty="0"/>
-          </a:p>
-        </p:txBody>
-      </p:sp>
-      <p:sp>
-        <p:nvSpPr>
-          <p:cNvPr id="4" name="Slide Number Placeholder 3"/>
-          <p:cNvSpPr>
-            <a:spLocks noGrp="1"/>
-          </p:cNvSpPr>
-          <p:nvPr>
-            <p:ph type="sldNum" sz="quarter" idx="10"/>
-          </p:nvPr>
-        </p:nvSpPr>
-        <p:spPr/>
-        <p:txBody>
-          <a:bodyPr/>
-          <a:lstStyle/>
-          <a:p>
-            <a:fld id="{F7021451-1387-4CA6-816F-3879F97B5CBC}" type="slidenum">
-              <a:rPr lang="en-US"/>
-              <a:t>4</a:t>
-            </a:fld>
-            <a:endParaRPr lang="en-US"/>
-          </a:p>
-        </p:txBody>
-      </p:sp>
-    </p:spTree>
-    <p:extLst>
-      <p:ext uri="{BB962C8B-B14F-4D97-AF65-F5344CB8AC3E}">
-        <p14:creationId xmlns:p14="http://schemas.microsoft.com/office/powerpoint/2010/main" val="1024086991"/>
-      </p:ext>
-    </p:extLst>
-  </p:cSld>
-  <p:clrMapOvr>
-    <a:masterClrMapping/>
-  </p:clrMapOvr>
-</p:notes>
-</file>
-
-<file path=ppt/notesSlides/notesSlide5.xml><?xml version="1.0" encoding="utf-8"?>
-<p:notes xmlns:a="http://schemas.openxmlformats.org/drawingml/2006/main" xmlns:r="http://schemas.openxmlformats.org/officeDocument/2006/relationships" xmlns:p="http://schemas.openxmlformats.org/presentationml/2006/main">
-  <p:cSld>
-    <p:spTree>
-      <p:nvGrpSpPr>
-        <p:cNvPr id="1" name=""/>
-        <p:cNvGrpSpPr/>
-        <p:nvPr/>
-      </p:nvGrpSpPr>
-      <p:grpSpPr>
-        <a:xfrm>
-          <a:off x="0" y="0"/>
-          <a:ext cx="0" cy="0"/>
-          <a:chOff x="0" y="0"/>
-          <a:chExt cx="0" cy="0"/>
-        </a:xfrm>
-      </p:grpSpPr>
-      <p:sp>
-        <p:nvSpPr>
-          <p:cNvPr id="2" name="Slide Image Placeholder 1"/>
-          <p:cNvSpPr>
-            <a:spLocks noGrp="1" noRot="1" noChangeAspect="1"/>
-          </p:cNvSpPr>
-          <p:nvPr>
-            <p:ph type="sldImg"/>
-          </p:nvPr>
-        </p:nvSpPr>
-        <p:spPr/>
-      </p:sp>
-      <p:sp>
-        <p:nvSpPr>
-          <p:cNvPr id="3" name="Notes Placeholder 2"/>
-          <p:cNvSpPr>
-            <a:spLocks noGrp="1"/>
-          </p:cNvSpPr>
-          <p:nvPr>
-            <p:ph type="body" idx="1"/>
-          </p:nvPr>
-        </p:nvSpPr>
-        <p:spPr/>
-        <p:txBody>
-          <a:bodyPr/>
-          <a:lstStyle/>
-          <a:p>
-            <a:r>
-              <a:rPr lang="en-US" dirty="0"/>
-              <a:t>The two critical numbers here are alpha and beta. Alpha = 0.10 means new shocks have moderate immediate impact. Beta = 0.80 means yesterday's vol heavily predicts today's vol. Their sum = 0.90 tells us vol is near-integrated — a crisis doesn't resolve in a day or two. Nu ≈ 5 confirms heavy tails — extreme moves happen more often than a normal distribution predicts, which is why we need Student-t rather than Gaussian errors.</a:t>
-            </a:r>
-            <a:endParaRPr lang="en-US" dirty="0"/>
-          </a:p>
-        </p:txBody>
-      </p:sp>
-      <p:sp>
-        <p:nvSpPr>
-          <p:cNvPr id="4" name="Slide Number Placeholder 3"/>
-          <p:cNvSpPr>
-            <a:spLocks noGrp="1"/>
-          </p:cNvSpPr>
-          <p:nvPr>
-            <p:ph type="sldNum" sz="quarter" idx="10"/>
-          </p:nvPr>
-        </p:nvSpPr>
-        <p:spPr/>
-        <p:txBody>
-          <a:bodyPr/>
-          <a:lstStyle/>
-          <a:p>
-            <a:fld id="{F7021451-1387-4CA6-816F-3879F97B5CBC}" type="slidenum">
-              <a:rPr lang="en-US"/>
-              <a:t>5</a:t>
-            </a:fld>
-            <a:endParaRPr lang="en-US"/>
-          </a:p>
-        </p:txBody>
-      </p:sp>
-    </p:spTree>
-    <p:extLst>
-      <p:ext uri="{BB962C8B-B14F-4D97-AF65-F5344CB8AC3E}">
-        <p14:creationId xmlns:p14="http://schemas.microsoft.com/office/powerpoint/2010/main" val="1024086991"/>
-      </p:ext>
-    </p:extLst>
-  </p:cSld>
-  <p:clrMapOvr>
-    <a:masterClrMapping/>
-  </p:clrMapOvr>
-</p:notes>
-</file>
-
-<file path=ppt/notesSlides/notesSlide6.xml><?xml version="1.0" encoding="utf-8"?>
-<p:notes xmlns:a="http://schemas.openxmlformats.org/drawingml/2006/main" xmlns:r="http://schemas.openxmlformats.org/officeDocument/2006/relationships" xmlns:p="http://schemas.openxmlformats.org/presentationml/2006/main">
-  <p:cSld>
-    <p:spTree>
-      <p:nvGrpSpPr>
-        <p:cNvPr id="1" name=""/>
-        <p:cNvGrpSpPr/>
-        <p:nvPr/>
-      </p:nvGrpSpPr>
-      <p:grpSpPr>
-        <a:xfrm>
-          <a:off x="0" y="0"/>
-          <a:ext cx="0" cy="0"/>
-          <a:chOff x="0" y="0"/>
-          <a:chExt cx="0" cy="0"/>
-        </a:xfrm>
-      </p:grpSpPr>
-      <p:sp>
-        <p:nvSpPr>
-          <p:cNvPr id="2" name="Slide Image Placeholder 1"/>
-          <p:cNvSpPr>
-            <a:spLocks noGrp="1" noRot="1" noChangeAspect="1"/>
-          </p:cNvSpPr>
-          <p:nvPr>
-            <p:ph type="sldImg"/>
-          </p:nvPr>
-        </p:nvSpPr>
-        <p:spPr/>
-      </p:sp>
-      <p:sp>
-        <p:nvSpPr>
-          <p:cNvPr id="3" name="Notes Placeholder 2"/>
-          <p:cNvSpPr>
-            <a:spLocks noGrp="1"/>
-          </p:cNvSpPr>
-          <p:nvPr>
-            <p:ph type="body" idx="1"/>
-          </p:nvPr>
-        </p:nvSpPr>
-        <p:spPr/>
-        <p:txBody>
-          <a:bodyPr/>
-          <a:lstStyle/>
-          <a:p>
-            <a:r>
-              <a:rPr lang="en-US" dirty="0"/>
-              <a:t>The GMM uses Bayesian Information Criterion to confirm k=4 is optimal — not 3, not 5. Each regime has statistically distinct mean and variance in the return space. Percentages are approximate from the fitted model on the full dataset. The key practical value: knowing which regime we're IN allows portfolio managers to size positions appropriately — not just react after the fact.</a:t>
-            </a:r>
-            <a:endParaRPr lang="en-US" dirty="0"/>
-          </a:p>
-        </p:txBody>
-      </p:sp>
-      <p:sp>
-        <p:nvSpPr>
-          <p:cNvPr id="4" name="Slide Number Placeholder 3"/>
-          <p:cNvSpPr>
-            <a:spLocks noGrp="1"/>
-          </p:cNvSpPr>
-          <p:nvPr>
-            <p:ph type="sldNum" sz="quarter" idx="10"/>
-          </p:nvPr>
-        </p:nvSpPr>
-        <p:spPr/>
-        <p:txBody>
-          <a:bodyPr/>
-          <a:lstStyle/>
-          <a:p>
-            <a:fld id="{F7021451-1387-4CA6-816F-3879F97B5CBC}" type="slidenum">
-              <a:rPr lang="en-US"/>
-              <a:t>6</a:t>
-            </a:fld>
-            <a:endParaRPr lang="en-US"/>
-          </a:p>
-        </p:txBody>
-      </p:sp>
-    </p:spTree>
-    <p:extLst>
-      <p:ext uri="{BB962C8B-B14F-4D97-AF65-F5344CB8AC3E}">
-        <p14:creationId xmlns:p14="http://schemas.microsoft.com/office/powerpoint/2010/main" val="1024086991"/>
-      </p:ext>
-    </p:extLst>
-  </p:cSld>
-  <p:clrMapOvr>
-    <a:masterClrMapping/>
-  </p:clrMapOvr>
-</p:notes>
-</file>
-
-<file path=ppt/notesSlides/notesSlide7.xml><?xml version="1.0" encoding="utf-8"?>
-<p:notes xmlns:a="http://schemas.openxmlformats.org/drawingml/2006/main" xmlns:r="http://schemas.openxmlformats.org/officeDocument/2006/relationships" xmlns:p="http://schemas.openxmlformats.org/presentationml/2006/main">
-  <p:cSld>
-    <p:spTree>
-      <p:nvGrpSpPr>
-        <p:cNvPr id="1" name=""/>
-        <p:cNvGrpSpPr/>
-        <p:nvPr/>
-      </p:nvGrpSpPr>
-      <p:grpSpPr>
-        <a:xfrm>
-          <a:off x="0" y="0"/>
-          <a:ext cx="0" cy="0"/>
-          <a:chOff x="0" y="0"/>
-          <a:chExt cx="0" cy="0"/>
-        </a:xfrm>
-      </p:grpSpPr>
-      <p:sp>
-        <p:nvSpPr>
-          <p:cNvPr id="2" name="Slide Image Placeholder 1"/>
-          <p:cNvSpPr>
-            <a:spLocks noGrp="1" noRot="1" noChangeAspect="1"/>
-          </p:cNvSpPr>
-          <p:nvPr>
-            <p:ph type="sldImg"/>
-          </p:nvPr>
-        </p:nvSpPr>
-        <p:spPr/>
-      </p:sp>
-      <p:sp>
-        <p:nvSpPr>
-          <p:cNvPr id="3" name="Notes Placeholder 2"/>
-          <p:cNvSpPr>
-            <a:spLocks noGrp="1"/>
-          </p:cNvSpPr>
-          <p:nvPr>
-            <p:ph type="body" idx="1"/>
-          </p:nvPr>
-        </p:nvSpPr>
-        <p:spPr/>
-        <p:txBody>
-          <a:bodyPr/>
-          <a:lstStyle/>
-          <a:p>
-            <a:r>
-              <a:rPr lang="en-US" dirty="0"/>
-              <a:t>This is the practical output. The annualised volatility by regime roughly follows: 14% in calm periods, 28% in trending markets, 45% in stress, 72% in crisis. That gap between regime 0 and regime 3 is a 5x difference in risk. A position-sizing framework that scales with regime can dramatically reduce drawdowns without sacrificing returns during calm periods.</a:t>
-            </a:r>
-            <a:endParaRPr lang="en-US" dirty="0"/>
-          </a:p>
-        </p:txBody>
-      </p:sp>
-      <p:sp>
-        <p:nvSpPr>
-          <p:cNvPr id="4" name="Slide Number Placeholder 3"/>
-          <p:cNvSpPr>
-            <a:spLocks noGrp="1"/>
-          </p:cNvSpPr>
-          <p:nvPr>
-            <p:ph type="sldNum" sz="quarter" idx="10"/>
-          </p:nvPr>
-        </p:nvSpPr>
-        <p:spPr/>
-        <p:txBody>
-          <a:bodyPr/>
-          <a:lstStyle/>
-          <a:p>
-            <a:fld id="{F7021451-1387-4CA6-816F-3879F97B5CBC}" type="slidenum">
-              <a:rPr lang="en-US"/>
-              <a:t>7</a:t>
-            </a:fld>
-            <a:endParaRPr lang="en-US"/>
-          </a:p>
-        </p:txBody>
-      </p:sp>
-    </p:spTree>
-    <p:extLst>
-      <p:ext uri="{BB962C8B-B14F-4D97-AF65-F5344CB8AC3E}">
-        <p14:creationId xmlns:p14="http://schemas.microsoft.com/office/powerpoint/2010/main" val="1024086991"/>
-      </p:ext>
-    </p:extLst>
-  </p:cSld>
-  <p:clrMapOvr>
-    <a:masterClrMapping/>
-  </p:clrMapOvr>
-</p:notes>
-</file>
-
-<file path=ppt/notesSlides/notesSlide8.xml><?xml version="1.0" encoding="utf-8"?>
-<p:notes xmlns:a="http://schemas.openxmlformats.org/drawingml/2006/main" xmlns:r="http://schemas.openxmlformats.org/officeDocument/2006/relationships" xmlns:p="http://schemas.openxmlformats.org/presentationml/2006/main">
-  <p:cSld>
-    <p:spTree>
-      <p:nvGrpSpPr>
-        <p:cNvPr id="1" name=""/>
-        <p:cNvGrpSpPr/>
-        <p:nvPr/>
-      </p:nvGrpSpPr>
-      <p:grpSpPr>
-        <a:xfrm>
-          <a:off x="0" y="0"/>
-          <a:ext cx="0" cy="0"/>
-          <a:chOff x="0" y="0"/>
-          <a:chExt cx="0" cy="0"/>
-        </a:xfrm>
-      </p:grpSpPr>
-      <p:sp>
-        <p:nvSpPr>
-          <p:cNvPr id="2" name="Slide Image Placeholder 1"/>
-          <p:cNvSpPr>
-            <a:spLocks noGrp="1" noRot="1" noChangeAspect="1"/>
-          </p:cNvSpPr>
-          <p:nvPr>
-            <p:ph type="sldImg"/>
-          </p:nvPr>
-        </p:nvSpPr>
-        <p:spPr/>
-      </p:sp>
-      <p:sp>
-        <p:nvSpPr>
-          <p:cNvPr id="3" name="Notes Placeholder 2"/>
-          <p:cNvSpPr>
-            <a:spLocks noGrp="1"/>
-          </p:cNvSpPr>
-          <p:nvPr>
-            <p:ph type="body" idx="1"/>
-          </p:nvPr>
-        </p:nvSpPr>
-        <p:spPr/>
-        <p:txBody>
-          <a:bodyPr/>
-          <a:lstStyle/>
-          <a:p>
-            <a:r>
-              <a:rPr lang="en-US" dirty="0"/>
-              <a:t>Pre-empt the question: 'Is this model validated?' Here's the honest, rigorous answer. The Kupiec test checks whether the VaR violation COUNT matches 5% — our GARCH-t conditional VaR passes it (5.9%, p=0.16). But count alone isn't enough, so we also run the Christoffersen independence test: it confirms our violations don't cluster (p=0.86). A naive constant VaR would pass Kupiec but FAIL Christoffersen — its breaches bunch up in volatile spells. So the model is validated on BOTH coverage and independence. GJR-GARCH and EVT are about sharpening the extreme tail for production, not repairing a failing model. That's a strong position.</a:t>
-            </a:r>
-            <a:endParaRPr lang="en-US" dirty="0"/>
-          </a:p>
-        </p:txBody>
-      </p:sp>
-      <p:sp>
-        <p:nvSpPr>
-          <p:cNvPr id="4" name="Slide Number Placeholder 3"/>
-          <p:cNvSpPr>
-            <a:spLocks noGrp="1"/>
-          </p:cNvSpPr>
-          <p:nvPr>
-            <p:ph type="sldNum" sz="quarter" idx="10"/>
-          </p:nvPr>
-        </p:nvSpPr>
-        <p:spPr/>
-        <p:txBody>
-          <a:bodyPr/>
-          <a:lstStyle/>
-          <a:p>
-            <a:fld id="{F7021451-1387-4CA6-816F-3879F97B5CBC}" type="slidenum">
-              <a:rPr lang="en-US"/>
-              <a:t>8</a:t>
-            </a:fld>
-            <a:endParaRPr lang="en-US"/>
-          </a:p>
-        </p:txBody>
-      </p:sp>
-    </p:spTree>
-    <p:extLst>
-      <p:ext uri="{BB962C8B-B14F-4D97-AF65-F5344CB8AC3E}">
-        <p14:creationId xmlns:p14="http://schemas.microsoft.com/office/powerpoint/2010/main" val="1024086991"/>
-      </p:ext>
-    </p:extLst>
-  </p:cSld>
-  <p:clrMapOvr>
-    <a:masterClrMapping/>
-  </p:clrMapOvr>
-</p:notes>
-</file>
-
-<file path=ppt/notesSlides/notesSlide9.xml><?xml version="1.0" encoding="utf-8"?>
-<p:notes xmlns:a="http://schemas.openxmlformats.org/drawingml/2006/main" xmlns:r="http://schemas.openxmlformats.org/officeDocument/2006/relationships" xmlns:p="http://schemas.openxmlformats.org/presentationml/2006/main">
-  <p:cSld>
-    <p:spTree>
-      <p:nvGrpSpPr>
-        <p:cNvPr id="1" name=""/>
-        <p:cNvGrpSpPr/>
-        <p:nvPr/>
-      </p:nvGrpSpPr>
-      <p:grpSpPr>
-        <a:xfrm>
-          <a:off x="0" y="0"/>
-          <a:ext cx="0" cy="0"/>
-          <a:chOff x="0" y="0"/>
-          <a:chExt cx="0" cy="0"/>
-        </a:xfrm>
-      </p:grpSpPr>
-      <p:sp>
-        <p:nvSpPr>
-          <p:cNvPr id="2" name="Slide Image Placeholder 1"/>
-          <p:cNvSpPr>
-            <a:spLocks noGrp="1" noRot="1" noChangeAspect="1"/>
-          </p:cNvSpPr>
-          <p:nvPr>
-            <p:ph type="sldImg"/>
-          </p:nvPr>
-        </p:nvSpPr>
-        <p:spPr/>
-      </p:sp>
-      <p:sp>
-        <p:nvSpPr>
-          <p:cNvPr id="3" name="Notes Placeholder 2"/>
-          <p:cNvSpPr>
-            <a:spLocks noGrp="1"/>
-          </p:cNvSpPr>
-          <p:nvPr>
-            <p:ph type="body" idx="1"/>
-          </p:nvPr>
-        </p:nvSpPr>
-        <p:spPr/>
-        <p:txBody>
-          <a:bodyPr/>
-          <a:lstStyle/>
-          <a:p>
-            <a:r>
-              <a:rPr lang="en-US" dirty="0"/>
-              <a:t>This is the moment where the analysis becomes real. Everything before this slide is methodology. This slide is the evidence. The Vodacom acquisition of a 20% additional stake — bringing total to 55% — represents a fundamental change in ownership structure, governance, and strategic direction. That IS a structural break by definition. Our regime detection framework exists precisely to identify moments like this in the price and volatility data.</a:t>
-            </a:r>
-            <a:endParaRPr lang="en-US" dirty="0"/>
-          </a:p>
-        </p:txBody>
-      </p:sp>
-      <p:sp>
-        <p:nvSpPr>
-          <p:cNvPr id="4" name="Slide Number Placeholder 3"/>
-          <p:cNvSpPr>
-            <a:spLocks noGrp="1"/>
-          </p:cNvSpPr>
-          <p:nvPr>
-            <p:ph type="sldNum" sz="quarter" idx="10"/>
-          </p:nvPr>
-        </p:nvSpPr>
-        <p:spPr/>
-        <p:txBody>
-          <a:bodyPr/>
-          <a:lstStyle/>
-          <a:p>
-            <a:fld id="{F7021451-1387-4CA6-816F-3879F97B5CBC}" type="slidenum">
-              <a:rPr lang="en-US"/>
-              <a:t>9</a:t>
-            </a:fld>
-            <a:endParaRPr lang="en-US"/>
-          </a:p>
-        </p:txBody>
-      </p:sp>
-    </p:spTree>
-    <p:extLst>
-      <p:ext uri="{BB962C8B-B14F-4D97-AF65-F5344CB8AC3E}">
-        <p14:creationId xmlns:p14="http://schemas.microsoft.com/office/powerpoint/2010/main" val="1024086991"/>
-      </p:ext>
-    </p:extLst>
-  </p:cSld>
-  <p:clrMapOvr>
-    <a:masterClrMapping/>
-  </p:clrMapOvr>
-</p:notes>
 </file>
 
 <file path=ppt/slideLayouts/slideLayout1.xml><?xml version="1.0" encoding="utf-8"?>

</xml_diff>